<commit_message>
edited template body size
</commit_message>
<xml_diff>
--- a/template1.pptx
+++ b/template1.pptx
@@ -6402,7 +6402,7 @@
           <p:nvPr>
             <p:extLst>
               <p:ext uri="{D42A27DB-BD31-4B8C-83A1-F6EECF244321}">
-                <p14:modId xmlns:p14="http://schemas.microsoft.com/office/powerpoint/2010/main" val="4188422416"/>
+                <p14:modId xmlns:p14="http://schemas.microsoft.com/office/powerpoint/2010/main" val="171168238"/>
               </p:ext>
             </p:extLst>
           </p:nvPr>
@@ -6462,7 +6462,7 @@
                           <a:cs typeface="Albert Sans"/>
                           <a:sym typeface="Albert Sans"/>
                         </a:rPr>
-                        <a:t>H</a:t>
+                        <a:t>Demo H</a:t>
                       </a:r>
                       <a:r>
                         <a:rPr lang="en-GB" sz="1100" b="1" dirty="0" err="1">
@@ -6553,7 +6553,7 @@
                           <a:cs typeface="Albert Sans"/>
                           <a:sym typeface="Albert Sans"/>
                         </a:rPr>
-                        <a:t>Body</a:t>
+                        <a:t>Demo Body</a:t>
                       </a:r>
                       <a:endParaRPr sz="1000" dirty="0">
                         <a:solidFill>
@@ -6860,10 +6860,10 @@
               <a:buNone/>
             </a:pPr>
             <a:r>
-              <a:rPr lang="en"/>
-              <a:t>Contents of this template</a:t>
+              <a:rPr lang="en" dirty="0"/>
+              <a:t>Demo Page</a:t>
             </a:r>
-            <a:endParaRPr/>
+            <a:endParaRPr dirty="0"/>
           </a:p>
         </p:txBody>
       </p:sp>

</xml_diff>

<commit_message>
edited template header size
</commit_message>
<xml_diff>
--- a/template1.pptx
+++ b/template1.pptx
@@ -6837,7 +6837,7 @@
         </p:nvSpPr>
         <p:spPr>
           <a:xfrm>
-            <a:off x="720000" y="445025"/>
+            <a:off x="726775" y="233678"/>
             <a:ext cx="7704000" cy="572700"/>
           </a:xfrm>
           <a:prstGeom prst="rect">
@@ -6860,10 +6860,10 @@
               <a:buNone/>
             </a:pPr>
             <a:r>
-              <a:rPr lang="en" dirty="0"/>
+              <a:rPr lang="en" sz="2800" dirty="0"/>
               <a:t>Demo Page</a:t>
             </a:r>
-            <a:endParaRPr dirty="0"/>
+            <a:endParaRPr sz="2800" dirty="0"/>
           </a:p>
         </p:txBody>
       </p:sp>

</xml_diff>

<commit_message>
password peek, out of tokens page responsiveness, project saving
</commit_message>
<xml_diff>
--- a/template1.pptx
+++ b/template1.pptx
@@ -6617,8 +6617,8 @@
         </p:nvSpPr>
         <p:spPr>
           <a:xfrm>
-            <a:off x="755169" y="151336"/>
-            <a:ext cx="7704000" cy="572700"/>
+            <a:off x="1534103" y="151336"/>
+            <a:ext cx="7327675" cy="572700"/>
           </a:xfrm>
           <a:prstGeom prst="rect">
             <a:avLst/>

</xml_diff>